<commit_message>
Fix deck script quoting, rebuild deck
Co-Authored-By: Claude Sonnet 5.5 <noreply@anthropic.com>
</commit_message>
<xml_diff>
--- a/submission/Kasi-Grid-deck.pptx
+++ b/submission/Kasi-Grid-deck.pptx
@@ -3158,7 +3158,7 @@
                 <a:ea typeface="Cambria" pitchFamily="34" charset="-122"/>
                 <a:cs typeface="Cambria" pitchFamily="34" charset="-120"/>
               </a:rPr>
-              <a:t>New this weekend: Outage Pulse</a:t>
+              <a:t>New this weekend: Pulse and Forecast</a:t>
             </a:r>
             <a:endParaRPr lang="en-US" sz="3400" dirty="0"/>
           </a:p>
@@ -3180,8 +3180,8 @@
         </p:blipFill>
         <p:spPr>
           <a:xfrm>
-            <a:off x="5852160" y="502920"/>
-            <a:ext cx="2098867" cy="4297680"/>
+            <a:off x="6903720" y="457200"/>
+            <a:ext cx="2009553" cy="4114800"/>
           </a:xfrm>
           <a:prstGeom prst="rect">
             <a:avLst/>
@@ -3204,7 +3204,7 @@
         <p:spPr>
           <a:xfrm>
             <a:off x="457200" y="1188720"/>
-            <a:ext cx="5029200" cy="3291840"/>
+            <a:ext cx="3566160" cy="3474720"/>
           </a:xfrm>
           <a:prstGeom prst="rect">
             <a:avLst/>
@@ -3224,7 +3224,7 @@
               <a:buChar char="•"/>
             </a:pPr>
             <a:r>
-              <a:rPr lang="en-US" sz="1600" dirty="0">
+              <a:rPr lang="en-US" sz="1400" dirty="0">
                 <a:solidFill>
                   <a:srgbClr val="FFFFFF"/>
                 </a:solidFill>
@@ -3232,9 +3232,9 @@
                 <a:ea typeface="Calibri" pitchFamily="34" charset="-122"/>
                 <a:cs typeface="Calibri" pitchFamily="34" charset="-120"/>
               </a:rPr>
-              <a:t>3+ different neighbours report the same power or water problem in a suburb within 6 hours, and it becomes a Verified outage</a:t>
-            </a:r>
-            <a:endParaRPr lang="en-US" sz="1600" dirty="0"/>
+              <a:t>Outage Pulse: 3+ different neighbours report the same problem and it becomes a Verified outage</a:t>
+            </a:r>
+            <a:endParaRPr lang="en-US" sz="1400" dirty="0"/>
           </a:p>
           <a:p>
             <a:pPr marL="342900" indent="-342900">
@@ -3245,7 +3245,7 @@
               <a:buChar char="•"/>
             </a:pPr>
             <a:r>
-              <a:rPr lang="en-US" sz="1600" dirty="0">
+              <a:rPr lang="en-US" sz="1400" dirty="0">
                 <a:solidFill>
                   <a:srgbClr val="FFFFFF"/>
                 </a:solidFill>
@@ -3253,9 +3253,9 @@
                 <a:ea typeface="Calibri" pitchFamily="34" charset="-122"/>
                 <a:cs typeface="Calibri" pitchFamily="34" charset="-120"/>
               </a:rPr>
-              <a:t>Neighbours vote "It is back on for me". Half agree (minimum 2) and the card turns green</a:t>
-            </a:r>
-            <a:endParaRPr lang="en-US" sz="1600" dirty="0"/>
+              <a:t>Neighbours vote "back on" and the alert closes itself</a:t>
+            </a:r>
+            <a:endParaRPr lang="en-US" sz="1400" dirty="0"/>
           </a:p>
           <a:p>
             <a:pPr marL="342900" indent="-342900">
@@ -3266,7 +3266,7 @@
               <a:buChar char="•"/>
             </a:pPr>
             <a:r>
-              <a:rPr lang="en-US" sz="1600" dirty="0">
+              <a:rPr lang="en-US" sz="1400" dirty="0">
                 <a:solidFill>
                   <a:srgbClr val="FFFFFF"/>
                 </a:solidFill>
@@ -3274,9 +3274,9 @@
                 <a:ea typeface="Calibri" pitchFamily="34" charset="-122"/>
                 <a:cs typeface="Calibri" pitchFamily="34" charset="-120"/>
               </a:rPr>
-              <a:t>Opt-in phone notification when a new verified outage appears</a:t>
-            </a:r>
-            <a:endParaRPr lang="en-US" sz="1600" dirty="0"/>
+              <a:t>Outage Forecast: learns the weekday and time-of-day pattern from its own reports</a:t>
+            </a:r>
+            <a:endParaRPr lang="en-US" sz="1400" dirty="0"/>
           </a:p>
           <a:p>
             <a:pPr marL="342900" indent="-342900">
@@ -3287,7 +3287,7 @@
               <a:buChar char="•"/>
             </a:pPr>
             <a:r>
-              <a:rPr lang="en-US" sz="1600" dirty="0">
+              <a:rPr lang="en-US" sz="1400" dirty="0">
                 <a:solidFill>
                   <a:srgbClr val="FFFFFF"/>
                 </a:solidFill>
@@ -3295,9 +3295,93 @@
                 <a:ea typeface="Calibri" pitchFamily="34" charset="-122"/>
                 <a:cs typeface="Calibri" pitchFamily="34" charset="-120"/>
               </a:rPr>
-              <a:t>Sample data and hidden posts are excluded. One vote per device</a:t>
-            </a:r>
-            <a:endParaRPr lang="en-US" sz="1600" dirty="0"/>
+              <a:t>Early warning at 2 reports, one short of verified</a:t>
+            </a:r>
+            <a:endParaRPr lang="en-US" sz="1400" dirty="0"/>
+          </a:p>
+          <a:p>
+            <a:pPr marL="342900" indent="-342900">
+              <a:spcAft>
+                <a:spcPts val="800"/>
+              </a:spcAft>
+              <a:buSzPct val="100000"/>
+              <a:buChar char="•"/>
+            </a:pPr>
+            <a:r>
+              <a:rPr lang="en-US" sz="1400" dirty="0">
+                <a:solidFill>
+                  <a:srgbClr val="FFFFFF"/>
+                </a:solidFill>
+                <a:latin typeface="Calibri" pitchFamily="34" charset="0"/>
+                <a:ea typeface="Calibri" pitchFamily="34" charset="-122"/>
+                <a:cs typeface="Calibri" pitchFamily="34" charset="-120"/>
+              </a:rPr>
+              <a:t>Opt-in phone notifications</a:t>
+            </a:r>
+            <a:endParaRPr lang="en-US" sz="1400" dirty="0"/>
+          </a:p>
+        </p:txBody>
+      </p:sp>
+      <p:pic>
+        <p:nvPicPr>
+          <p:cNvPr id="5" name="Image 1" descr="shots/forecast.png">    </p:cNvPr>
+          <p:cNvPicPr>
+            <a:picLocks noChangeAspect="1"/>
+          </p:cNvPicPr>
+          <p:nvPr/>
+        </p:nvPicPr>
+        <p:blipFill>
+          <a:blip r:embed="rId2"/>
+          <a:stretch>
+            <a:fillRect/>
+          </a:stretch>
+        </p:blipFill>
+        <p:spPr>
+          <a:xfrm>
+            <a:off x="4297680" y="1280160"/>
+            <a:ext cx="2377440" cy="1856609"/>
+          </a:xfrm>
+          <a:prstGeom prst="rect">
+            <a:avLst/>
+          </a:prstGeom>
+        </p:spPr>
+      </p:pic>
+      <p:sp>
+        <p:nvSpPr>
+          <p:cNvPr id="6" name="Text 2"/>
+          <p:cNvSpPr txBox="1"/>
+          <p:nvPr/>
+        </p:nvSpPr>
+        <p:spPr>
+          <a:xfrm>
+            <a:off x="4297680" y="3246120"/>
+            <a:ext cx="2377440" cy="822960"/>
+          </a:xfrm>
+          <a:prstGeom prst="rect">
+            <a:avLst/>
+          </a:prstGeom>
+          <a:noFill/>
+          <a:ln/>
+        </p:spPr>
+        <p:txBody>
+          <a:bodyPr wrap="square" lIns="0" tIns="0" rIns="0" bIns="0" rtlCol="0" anchor="t"/>
+          <a:lstStyle/>
+          <a:p>
+            <a:pPr indent="0" marL="0">
+              <a:buNone/>
+            </a:pPr>
+            <a:r>
+              <a:rPr lang="en-US" sz="1200" i="1" dirty="0">
+                <a:solidFill>
+                  <a:srgbClr val="CFE3E1"/>
+                </a:solidFill>
+                <a:latin typeface="Calibri" pitchFamily="34" charset="0"/>
+                <a:ea typeface="Calibri" pitchFamily="34" charset="-122"/>
+                <a:cs typeface="Calibri" pitchFamily="34" charset="-120"/>
+              </a:rPr>
+              <a:t>Rule-based and transparent: it shows its confidence and says when there is not enough data.</a:t>
+            </a:r>
+            <a:endParaRPr lang="en-US" sz="1200" dirty="0"/>
           </a:p>
         </p:txBody>
       </p:sp>
@@ -5701,6 +5785,27 @@
                 <a:cs typeface="Calibri" pitchFamily="34" charset="-120"/>
               </a:rPr>
               <a:t>Data ownership: all community data sits in our own database, exportable and anonymous</a:t>
+            </a:r>
+            <a:endParaRPr lang="en-US" sz="1600" dirty="0"/>
+          </a:p>
+          <a:p>
+            <a:pPr marL="342900" indent="-342900">
+              <a:spcAft>
+                <a:spcPts val="800"/>
+              </a:spcAft>
+              <a:buSzPct val="100000"/>
+              <a:buChar char="•"/>
+            </a:pPr>
+            <a:r>
+              <a:rPr lang="en-US" sz="1600" dirty="0">
+                <a:solidFill>
+                  <a:srgbClr val="FFFFFF"/>
+                </a:solidFill>
+                <a:latin typeface="Calibri" pitchFamily="34" charset="0"/>
+                <a:ea typeface="Calibri" pitchFamily="34" charset="-122"/>
+                <a:cs typeface="Calibri" pitchFamily="34" charset="-120"/>
+              </a:rPr>
+              <a:t>Pilot: [N] neighbours in [SUBURB], [N] reports, [N] verified outages</a:t>
             </a:r>
             <a:endParaRPr lang="en-US" sz="1600" dirty="0"/>
           </a:p>

</xml_diff>

<commit_message>
Retheme to pastel purple and baby blue (app, icons, deck)
Co-Authored-By: Claude Sonnet 5.5 <noreply@anthropic.com>
</commit_message>
<xml_diff>
--- a/submission/Kasi-Grid-deck.pptx
+++ b/submission/Kasi-Grid-deck.pptx
@@ -1658,7 +1658,7 @@
     <p:bg>
       <p:bgPr>
         <a:solidFill>
-          <a:srgbClr val="0B3D3D"/>
+          <a:srgbClr val="2E2457"/>
         </a:solidFill>
       </p:bgPr>
     </p:bg>
@@ -1742,7 +1742,7 @@
             <a:r>
               <a:rPr lang="en-US" sz="2400" i="1" dirty="0">
                 <a:solidFill>
-                  <a:srgbClr val="F2A33A"/>
+                  <a:srgbClr val="9FD3F0"/>
                 </a:solidFill>
                 <a:latin typeface="Cambria" pitchFamily="34" charset="0"/>
                 <a:ea typeface="Cambria" pitchFamily="34" charset="-122"/>
@@ -1781,7 +1781,7 @@
             <a:r>
               <a:rPr lang="en-US" sz="1600" dirty="0">
                 <a:solidFill>
-                  <a:srgbClr val="CFE3E1"/>
+                  <a:srgbClr val="DDD4F6"/>
                 </a:solidFill>
                 <a:latin typeface="Calibri" pitchFamily="34" charset="0"/>
                 <a:ea typeface="Calibri" pitchFamily="34" charset="-122"/>
@@ -1820,7 +1820,7 @@
             <a:r>
               <a:rPr lang="en-US" sz="1200" dirty="0">
                 <a:solidFill>
-                  <a:srgbClr val="CFE3E1"/>
+                  <a:srgbClr val="DDD4F6"/>
                 </a:solidFill>
                 <a:latin typeface="Calibri" pitchFamily="34" charset="0"/>
                 <a:ea typeface="Calibri" pitchFamily="34" charset="-122"/>
@@ -1922,7 +1922,7 @@
             <a:r>
               <a:rPr lang="en-US" sz="3400" b="1" dirty="0">
                 <a:solidFill>
-                  <a:srgbClr val="0B3D3D"/>
+                  <a:srgbClr val="2E2457"/>
                 </a:solidFill>
                 <a:latin typeface="Cambria" pitchFamily="34" charset="0"/>
                 <a:ea typeface="Cambria" pitchFamily="34" charset="-122"/>
@@ -1951,11 +1951,11 @@
             </a:avLst>
           </a:prstGeom>
           <a:solidFill>
-            <a:srgbClr val="F4F6F5"/>
+            <a:srgbClr val="F4F1FC"/>
           </a:solidFill>
           <a:ln w="12700">
             <a:solidFill>
-              <a:srgbClr val="F4F6F5"/>
+              <a:srgbClr val="F4F1FC"/>
             </a:solidFill>
             <a:prstDash val="solid"/>
           </a:ln>
@@ -1988,7 +1988,7 @@
             <a:r>
               <a:rPr lang="en-US" sz="1800" b="1" dirty="0">
                 <a:solidFill>
-                  <a:srgbClr val="0B6E6E"/>
+                  <a:srgbClr val="6A57B8"/>
                 </a:solidFill>
                 <a:latin typeface="Cambria" pitchFamily="34" charset="0"/>
                 <a:ea typeface="Cambria" pitchFamily="34" charset="-122"/>
@@ -2027,7 +2027,7 @@
             <a:r>
               <a:rPr lang="en-US" sz="1400" dirty="0">
                 <a:solidFill>
-                  <a:srgbClr val="16211F"/>
+                  <a:srgbClr val="241F38"/>
                 </a:solidFill>
                 <a:latin typeface="Calibri" pitchFamily="34" charset="0"/>
                 <a:ea typeface="Calibri" pitchFamily="34" charset="-122"/>
@@ -2044,7 +2044,7 @@
             <a:r>
               <a:rPr lang="en-US" sz="1400" dirty="0">
                 <a:solidFill>
-                  <a:srgbClr val="16211F"/>
+                  <a:srgbClr val="241F38"/>
                 </a:solidFill>
                 <a:latin typeface="Calibri" pitchFamily="34" charset="0"/>
                 <a:ea typeface="Calibri" pitchFamily="34" charset="-122"/>
@@ -2061,7 +2061,7 @@
             <a:r>
               <a:rPr lang="en-US" sz="1400" dirty="0">
                 <a:solidFill>
-                  <a:srgbClr val="16211F"/>
+                  <a:srgbClr val="241F38"/>
                 </a:solidFill>
                 <a:latin typeface="Calibri" pitchFamily="34" charset="0"/>
                 <a:ea typeface="Calibri" pitchFamily="34" charset="-122"/>
@@ -2078,7 +2078,7 @@
             <a:r>
               <a:rPr lang="en-US" sz="1400" dirty="0">
                 <a:solidFill>
-                  <a:srgbClr val="16211F"/>
+                  <a:srgbClr val="241F38"/>
                 </a:solidFill>
                 <a:latin typeface="Calibri" pitchFamily="34" charset="0"/>
                 <a:ea typeface="Calibri" pitchFamily="34" charset="-122"/>
@@ -2107,11 +2107,11 @@
             </a:avLst>
           </a:prstGeom>
           <a:solidFill>
-            <a:srgbClr val="F4F6F5"/>
+            <a:srgbClr val="F4F1FC"/>
           </a:solidFill>
           <a:ln w="12700">
             <a:solidFill>
-              <a:srgbClr val="F4F6F5"/>
+              <a:srgbClr val="F4F1FC"/>
             </a:solidFill>
             <a:prstDash val="solid"/>
           </a:ln>
@@ -2144,7 +2144,7 @@
             <a:r>
               <a:rPr lang="en-US" sz="1800" b="1" dirty="0">
                 <a:solidFill>
-                  <a:srgbClr val="0B6E6E"/>
+                  <a:srgbClr val="6A57B8"/>
                 </a:solidFill>
                 <a:latin typeface="Cambria" pitchFamily="34" charset="0"/>
                 <a:ea typeface="Cambria" pitchFamily="34" charset="-122"/>
@@ -2183,7 +2183,7 @@
             <a:r>
               <a:rPr lang="en-US" sz="1400" dirty="0">
                 <a:solidFill>
-                  <a:srgbClr val="16211F"/>
+                  <a:srgbClr val="241F38"/>
                 </a:solidFill>
                 <a:latin typeface="Calibri" pitchFamily="34" charset="0"/>
                 <a:ea typeface="Calibri" pitchFamily="34" charset="-122"/>
@@ -2200,7 +2200,7 @@
             <a:r>
               <a:rPr lang="en-US" sz="1400" dirty="0">
                 <a:solidFill>
-                  <a:srgbClr val="16211F"/>
+                  <a:srgbClr val="241F38"/>
                 </a:solidFill>
                 <a:latin typeface="Calibri" pitchFamily="34" charset="0"/>
                 <a:ea typeface="Calibri" pitchFamily="34" charset="-122"/>
@@ -2217,7 +2217,7 @@
             <a:r>
               <a:rPr lang="en-US" sz="1400" dirty="0">
                 <a:solidFill>
-                  <a:srgbClr val="16211F"/>
+                  <a:srgbClr val="241F38"/>
                 </a:solidFill>
                 <a:latin typeface="Calibri" pitchFamily="34" charset="0"/>
                 <a:ea typeface="Calibri" pitchFamily="34" charset="-122"/>
@@ -2234,7 +2234,7 @@
             <a:r>
               <a:rPr lang="en-US" sz="1400" dirty="0">
                 <a:solidFill>
-                  <a:srgbClr val="16211F"/>
+                  <a:srgbClr val="241F38"/>
                 </a:solidFill>
                 <a:latin typeface="Calibri" pitchFamily="34" charset="0"/>
                 <a:ea typeface="Calibri" pitchFamily="34" charset="-122"/>
@@ -2251,7 +2251,7 @@
             <a:r>
               <a:rPr lang="en-US" sz="1400" dirty="0">
                 <a:solidFill>
-                  <a:srgbClr val="16211F"/>
+                  <a:srgbClr val="241F38"/>
                 </a:solidFill>
                 <a:latin typeface="Calibri" pitchFamily="34" charset="0"/>
                 <a:ea typeface="Calibri" pitchFamily="34" charset="-122"/>
@@ -2274,7 +2274,7 @@
             <a:r>
               <a:rPr lang="en-US" sz="1400" dirty="0">
                 <a:solidFill>
-                  <a:srgbClr val="16211F"/>
+                  <a:srgbClr val="241F38"/>
                 </a:solidFill>
                 <a:latin typeface="Calibri" pitchFamily="34" charset="0"/>
                 <a:ea typeface="Calibri" pitchFamily="34" charset="-122"/>
@@ -2345,7 +2345,7 @@
             <a:r>
               <a:rPr lang="en-US" sz="3400" b="1" dirty="0">
                 <a:solidFill>
-                  <a:srgbClr val="0B3D3D"/>
+                  <a:srgbClr val="2E2457"/>
                 </a:solidFill>
                 <a:latin typeface="Cambria" pitchFamily="34" charset="0"/>
                 <a:ea typeface="Cambria" pitchFamily="34" charset="-122"/>
@@ -2374,11 +2374,11 @@
             </a:avLst>
           </a:prstGeom>
           <a:solidFill>
-            <a:srgbClr val="F4F6F5"/>
+            <a:srgbClr val="F4F1FC"/>
           </a:solidFill>
           <a:ln w="12700">
             <a:solidFill>
-              <a:srgbClr val="F4F6F5"/>
+              <a:srgbClr val="F4F1FC"/>
             </a:solidFill>
             <a:prstDash val="solid"/>
           </a:ln>
@@ -2411,7 +2411,7 @@
             <a:r>
               <a:rPr lang="en-US" sz="1800" b="1" dirty="0">
                 <a:solidFill>
-                  <a:srgbClr val="0B6E6E"/>
+                  <a:srgbClr val="6A57B8"/>
                 </a:solidFill>
                 <a:latin typeface="Cambria" pitchFamily="34" charset="0"/>
                 <a:ea typeface="Cambria" pitchFamily="34" charset="-122"/>
@@ -2450,7 +2450,7 @@
             <a:r>
               <a:rPr lang="en-US" sz="1400" dirty="0">
                 <a:solidFill>
-                  <a:srgbClr val="16211F"/>
+                  <a:srgbClr val="241F38"/>
                 </a:solidFill>
                 <a:latin typeface="Calibri" pitchFamily="34" charset="0"/>
                 <a:ea typeface="Calibri" pitchFamily="34" charset="-122"/>
@@ -2479,11 +2479,11 @@
             </a:avLst>
           </a:prstGeom>
           <a:solidFill>
-            <a:srgbClr val="F4F6F5"/>
+            <a:srgbClr val="F4F1FC"/>
           </a:solidFill>
           <a:ln w="12700">
             <a:solidFill>
-              <a:srgbClr val="F4F6F5"/>
+              <a:srgbClr val="F4F1FC"/>
             </a:solidFill>
             <a:prstDash val="solid"/>
           </a:ln>
@@ -2516,7 +2516,7 @@
             <a:r>
               <a:rPr lang="en-US" sz="1800" b="1" dirty="0">
                 <a:solidFill>
-                  <a:srgbClr val="0B6E6E"/>
+                  <a:srgbClr val="6A57B8"/>
                 </a:solidFill>
                 <a:latin typeface="Cambria" pitchFamily="34" charset="0"/>
                 <a:ea typeface="Cambria" pitchFamily="34" charset="-122"/>
@@ -2555,7 +2555,7 @@
             <a:r>
               <a:rPr lang="en-US" sz="1400" dirty="0">
                 <a:solidFill>
-                  <a:srgbClr val="16211F"/>
+                  <a:srgbClr val="241F38"/>
                 </a:solidFill>
                 <a:latin typeface="Calibri" pitchFamily="34" charset="0"/>
                 <a:ea typeface="Calibri" pitchFamily="34" charset="-122"/>
@@ -2584,11 +2584,11 @@
             </a:avLst>
           </a:prstGeom>
           <a:solidFill>
-            <a:srgbClr val="F4F6F5"/>
+            <a:srgbClr val="F4F1FC"/>
           </a:solidFill>
           <a:ln w="12700">
             <a:solidFill>
-              <a:srgbClr val="F4F6F5"/>
+              <a:srgbClr val="F4F1FC"/>
             </a:solidFill>
             <a:prstDash val="solid"/>
           </a:ln>
@@ -2621,7 +2621,7 @@
             <a:r>
               <a:rPr lang="en-US" sz="1800" b="1" dirty="0">
                 <a:solidFill>
-                  <a:srgbClr val="0B6E6E"/>
+                  <a:srgbClr val="6A57B8"/>
                 </a:solidFill>
                 <a:latin typeface="Cambria" pitchFamily="34" charset="0"/>
                 <a:ea typeface="Cambria" pitchFamily="34" charset="-122"/>
@@ -2660,7 +2660,7 @@
             <a:r>
               <a:rPr lang="en-US" sz="1400" dirty="0">
                 <a:solidFill>
-                  <a:srgbClr val="16211F"/>
+                  <a:srgbClr val="241F38"/>
                 </a:solidFill>
                 <a:latin typeface="Calibri" pitchFamily="34" charset="0"/>
                 <a:ea typeface="Calibri" pitchFamily="34" charset="-122"/>
@@ -2699,7 +2699,7 @@
             <a:r>
               <a:rPr lang="en-US" sz="2000" i="1" dirty="0">
                 <a:solidFill>
-                  <a:srgbClr val="0B3D3D"/>
+                  <a:srgbClr val="2E2457"/>
                 </a:solidFill>
                 <a:latin typeface="Cambria" pitchFamily="34" charset="0"/>
                 <a:ea typeface="Cambria" pitchFamily="34" charset="-122"/>
@@ -2770,7 +2770,7 @@
             <a:r>
               <a:rPr lang="en-US" sz="3400" b="1" dirty="0">
                 <a:solidFill>
-                  <a:srgbClr val="0B3D3D"/>
+                  <a:srgbClr val="2E2457"/>
                 </a:solidFill>
                 <a:latin typeface="Cambria" pitchFamily="34" charset="0"/>
                 <a:ea typeface="Cambria" pitchFamily="34" charset="-122"/>
@@ -2840,7 +2840,7 @@
             <a:r>
               <a:rPr lang="en-US" sz="1400" b="1" dirty="0">
                 <a:solidFill>
-                  <a:srgbClr val="0B6E6E"/>
+                  <a:srgbClr val="6A57B8"/>
                 </a:solidFill>
                 <a:latin typeface="Calibri" pitchFamily="34" charset="0"/>
                 <a:ea typeface="Calibri" pitchFamily="34" charset="-122"/>
@@ -2857,7 +2857,7 @@
             <a:r>
               <a:rPr lang="en-US" sz="1400" dirty="0">
                 <a:solidFill>
-                  <a:srgbClr val="16211F"/>
+                  <a:srgbClr val="241F38"/>
                 </a:solidFill>
                 <a:latin typeface="Calibri" pitchFamily="34" charset="0"/>
                 <a:ea typeface="Calibri" pitchFamily="34" charset="-122"/>
@@ -2896,7 +2896,7 @@
             <a:r>
               <a:rPr lang="en-US" sz="1400" b="1" dirty="0">
                 <a:solidFill>
-                  <a:srgbClr val="0B6E6E"/>
+                  <a:srgbClr val="6A57B8"/>
                 </a:solidFill>
                 <a:latin typeface="Calibri" pitchFamily="34" charset="0"/>
                 <a:ea typeface="Calibri" pitchFamily="34" charset="-122"/>
@@ -2913,7 +2913,7 @@
             <a:r>
               <a:rPr lang="en-US" sz="1400" dirty="0">
                 <a:solidFill>
-                  <a:srgbClr val="16211F"/>
+                  <a:srgbClr val="241F38"/>
                 </a:solidFill>
                 <a:latin typeface="Calibri" pitchFamily="34" charset="0"/>
                 <a:ea typeface="Calibri" pitchFamily="34" charset="-122"/>
@@ -2952,7 +2952,7 @@
             <a:r>
               <a:rPr lang="en-US" sz="1400" b="1" dirty="0">
                 <a:solidFill>
-                  <a:srgbClr val="0B6E6E"/>
+                  <a:srgbClr val="6A57B8"/>
                 </a:solidFill>
                 <a:latin typeface="Calibri" pitchFamily="34" charset="0"/>
                 <a:ea typeface="Calibri" pitchFamily="34" charset="-122"/>
@@ -2969,7 +2969,7 @@
             <a:r>
               <a:rPr lang="en-US" sz="1400" dirty="0">
                 <a:solidFill>
-                  <a:srgbClr val="16211F"/>
+                  <a:srgbClr val="241F38"/>
                 </a:solidFill>
                 <a:latin typeface="Calibri" pitchFamily="34" charset="0"/>
                 <a:ea typeface="Calibri" pitchFamily="34" charset="-122"/>
@@ -3008,7 +3008,7 @@
             <a:r>
               <a:rPr lang="en-US" sz="1400" b="1" dirty="0">
                 <a:solidFill>
-                  <a:srgbClr val="0B6E6E"/>
+                  <a:srgbClr val="6A57B8"/>
                 </a:solidFill>
                 <a:latin typeface="Calibri" pitchFamily="34" charset="0"/>
                 <a:ea typeface="Calibri" pitchFamily="34" charset="-122"/>
@@ -3025,7 +3025,7 @@
             <a:r>
               <a:rPr lang="en-US" sz="1400" dirty="0">
                 <a:solidFill>
-                  <a:srgbClr val="16211F"/>
+                  <a:srgbClr val="241F38"/>
                 </a:solidFill>
                 <a:latin typeface="Calibri" pitchFamily="34" charset="0"/>
                 <a:ea typeface="Calibri" pitchFamily="34" charset="-122"/>
@@ -3064,7 +3064,7 @@
             <a:r>
               <a:rPr lang="en-US" sz="1400" b="1" dirty="0">
                 <a:solidFill>
-                  <a:srgbClr val="0B6E6E"/>
+                  <a:srgbClr val="6A57B8"/>
                 </a:solidFill>
                 <a:latin typeface="Calibri" pitchFamily="34" charset="0"/>
                 <a:ea typeface="Calibri" pitchFamily="34" charset="-122"/>
@@ -3081,7 +3081,7 @@
             <a:r>
               <a:rPr lang="en-US" sz="1400" dirty="0">
                 <a:solidFill>
-                  <a:srgbClr val="16211F"/>
+                  <a:srgbClr val="241F38"/>
                 </a:solidFill>
                 <a:latin typeface="Calibri" pitchFamily="34" charset="0"/>
                 <a:ea typeface="Calibri" pitchFamily="34" charset="-122"/>
@@ -3107,7 +3107,7 @@
     <p:bg>
       <p:bgPr>
         <a:solidFill>
-          <a:srgbClr val="0B3D3D"/>
+          <a:srgbClr val="2E2457"/>
         </a:solidFill>
       </p:bgPr>
     </p:bg>
@@ -3373,7 +3373,7 @@
             <a:r>
               <a:rPr lang="en-US" sz="1200" i="1" dirty="0">
                 <a:solidFill>
-                  <a:srgbClr val="CFE3E1"/>
+                  <a:srgbClr val="DDD4F6"/>
                 </a:solidFill>
                 <a:latin typeface="Calibri" pitchFamily="34" charset="0"/>
                 <a:ea typeface="Calibri" pitchFamily="34" charset="-122"/>
@@ -3444,7 +3444,7 @@
             <a:r>
               <a:rPr lang="en-US" sz="3400" b="1" dirty="0">
                 <a:solidFill>
-                  <a:srgbClr val="0B3D3D"/>
+                  <a:srgbClr val="2E2457"/>
                 </a:solidFill>
                 <a:latin typeface="Cambria" pitchFamily="34" charset="0"/>
                 <a:ea typeface="Cambria" pitchFamily="34" charset="-122"/>
@@ -3471,11 +3471,11 @@
             <a:avLst/>
           </a:prstGeom>
           <a:solidFill>
-            <a:srgbClr val="0B6E6E"/>
+            <a:srgbClr val="6A57B8"/>
           </a:solidFill>
           <a:ln w="12700">
             <a:solidFill>
-              <a:srgbClr val="0B6E6E"/>
+              <a:srgbClr val="6A57B8"/>
             </a:solidFill>
             <a:prstDash val="solid"/>
           </a:ln>
@@ -3547,7 +3547,7 @@
             <a:r>
               <a:rPr lang="en-US" sz="1600" b="1" dirty="0">
                 <a:solidFill>
-                  <a:srgbClr val="0B3D3D"/>
+                  <a:srgbClr val="2E2457"/>
                 </a:solidFill>
                 <a:latin typeface="Cambria" pitchFamily="34" charset="0"/>
                 <a:ea typeface="Cambria" pitchFamily="34" charset="-122"/>
@@ -3586,7 +3586,7 @@
             <a:r>
               <a:rPr lang="en-US" sz="1400" dirty="0">
                 <a:solidFill>
-                  <a:srgbClr val="16211F"/>
+                  <a:srgbClr val="241F38"/>
                 </a:solidFill>
                 <a:latin typeface="Calibri" pitchFamily="34" charset="0"/>
                 <a:ea typeface="Calibri" pitchFamily="34" charset="-122"/>
@@ -3613,11 +3613,11 @@
             <a:avLst/>
           </a:prstGeom>
           <a:solidFill>
-            <a:srgbClr val="0B6E6E"/>
+            <a:srgbClr val="6A57B8"/>
           </a:solidFill>
           <a:ln w="12700">
             <a:solidFill>
-              <a:srgbClr val="0B6E6E"/>
+              <a:srgbClr val="6A57B8"/>
             </a:solidFill>
             <a:prstDash val="solid"/>
           </a:ln>
@@ -3689,7 +3689,7 @@
             <a:r>
               <a:rPr lang="en-US" sz="1600" b="1" dirty="0">
                 <a:solidFill>
-                  <a:srgbClr val="0B3D3D"/>
+                  <a:srgbClr val="2E2457"/>
                 </a:solidFill>
                 <a:latin typeface="Cambria" pitchFamily="34" charset="0"/>
                 <a:ea typeface="Cambria" pitchFamily="34" charset="-122"/>
@@ -3728,7 +3728,7 @@
             <a:r>
               <a:rPr lang="en-US" sz="1400" dirty="0">
                 <a:solidFill>
-                  <a:srgbClr val="16211F"/>
+                  <a:srgbClr val="241F38"/>
                 </a:solidFill>
                 <a:latin typeface="Calibri" pitchFamily="34" charset="0"/>
                 <a:ea typeface="Calibri" pitchFamily="34" charset="-122"/>
@@ -3755,11 +3755,11 @@
             <a:avLst/>
           </a:prstGeom>
           <a:solidFill>
-            <a:srgbClr val="0B6E6E"/>
+            <a:srgbClr val="6A57B8"/>
           </a:solidFill>
           <a:ln w="12700">
             <a:solidFill>
-              <a:srgbClr val="0B6E6E"/>
+              <a:srgbClr val="6A57B8"/>
             </a:solidFill>
             <a:prstDash val="solid"/>
           </a:ln>
@@ -3831,7 +3831,7 @@
             <a:r>
               <a:rPr lang="en-US" sz="1600" b="1" dirty="0">
                 <a:solidFill>
-                  <a:srgbClr val="0B3D3D"/>
+                  <a:srgbClr val="2E2457"/>
                 </a:solidFill>
                 <a:latin typeface="Cambria" pitchFamily="34" charset="0"/>
                 <a:ea typeface="Cambria" pitchFamily="34" charset="-122"/>
@@ -3870,7 +3870,7 @@
             <a:r>
               <a:rPr lang="en-US" sz="1400" dirty="0">
                 <a:solidFill>
-                  <a:srgbClr val="16211F"/>
+                  <a:srgbClr val="241F38"/>
                 </a:solidFill>
                 <a:latin typeface="Calibri" pitchFamily="34" charset="0"/>
                 <a:ea typeface="Calibri" pitchFamily="34" charset="-122"/>
@@ -3897,11 +3897,11 @@
             <a:avLst/>
           </a:prstGeom>
           <a:solidFill>
-            <a:srgbClr val="0B6E6E"/>
+            <a:srgbClr val="6A57B8"/>
           </a:solidFill>
           <a:ln w="12700">
             <a:solidFill>
-              <a:srgbClr val="0B6E6E"/>
+              <a:srgbClr val="6A57B8"/>
             </a:solidFill>
             <a:prstDash val="solid"/>
           </a:ln>
@@ -3973,7 +3973,7 @@
             <a:r>
               <a:rPr lang="en-US" sz="1600" b="1" dirty="0">
                 <a:solidFill>
-                  <a:srgbClr val="0B3D3D"/>
+                  <a:srgbClr val="2E2457"/>
                 </a:solidFill>
                 <a:latin typeface="Cambria" pitchFamily="34" charset="0"/>
                 <a:ea typeface="Cambria" pitchFamily="34" charset="-122"/>
@@ -4012,7 +4012,7 @@
             <a:r>
               <a:rPr lang="en-US" sz="1400" dirty="0">
                 <a:solidFill>
-                  <a:srgbClr val="16211F"/>
+                  <a:srgbClr val="241F38"/>
                 </a:solidFill>
                 <a:latin typeface="Calibri" pitchFamily="34" charset="0"/>
                 <a:ea typeface="Calibri" pitchFamily="34" charset="-122"/>
@@ -4039,11 +4039,11 @@
             <a:avLst/>
           </a:prstGeom>
           <a:solidFill>
-            <a:srgbClr val="0B6E6E"/>
+            <a:srgbClr val="6A57B8"/>
           </a:solidFill>
           <a:ln w="12700">
             <a:solidFill>
-              <a:srgbClr val="0B6E6E"/>
+              <a:srgbClr val="6A57B8"/>
             </a:solidFill>
             <a:prstDash val="solid"/>
           </a:ln>
@@ -4115,7 +4115,7 @@
             <a:r>
               <a:rPr lang="en-US" sz="1600" b="1" dirty="0">
                 <a:solidFill>
-                  <a:srgbClr val="0B3D3D"/>
+                  <a:srgbClr val="2E2457"/>
                 </a:solidFill>
                 <a:latin typeface="Cambria" pitchFamily="34" charset="0"/>
                 <a:ea typeface="Cambria" pitchFamily="34" charset="-122"/>
@@ -4154,7 +4154,7 @@
             <a:r>
               <a:rPr lang="en-US" sz="1400" dirty="0">
                 <a:solidFill>
-                  <a:srgbClr val="16211F"/>
+                  <a:srgbClr val="241F38"/>
                 </a:solidFill>
                 <a:latin typeface="Calibri" pitchFamily="34" charset="0"/>
                 <a:ea typeface="Calibri" pitchFamily="34" charset="-122"/>
@@ -4225,7 +4225,7 @@
             <a:r>
               <a:rPr lang="en-US" sz="3400" b="1" dirty="0">
                 <a:solidFill>
-                  <a:srgbClr val="0B3D3D"/>
+                  <a:srgbClr val="2E2457"/>
                 </a:solidFill>
                 <a:latin typeface="Cambria" pitchFamily="34" charset="0"/>
                 <a:ea typeface="Cambria" pitchFamily="34" charset="-122"/>
@@ -4361,7 +4361,7 @@
             <a:r>
               <a:rPr lang="en-US" sz="1400" dirty="0">
                 <a:solidFill>
-                  <a:srgbClr val="16211F"/>
+                  <a:srgbClr val="241F38"/>
                 </a:solidFill>
                 <a:latin typeface="Calibri" pitchFamily="34" charset="0"/>
                 <a:ea typeface="Calibri" pitchFamily="34" charset="-122"/>
@@ -4382,7 +4382,7 @@
             <a:r>
               <a:rPr lang="en-US" sz="1400" dirty="0">
                 <a:solidFill>
-                  <a:srgbClr val="16211F"/>
+                  <a:srgbClr val="241F38"/>
                 </a:solidFill>
                 <a:latin typeface="Calibri" pitchFamily="34" charset="0"/>
                 <a:ea typeface="Calibri" pitchFamily="34" charset="-122"/>
@@ -4403,7 +4403,7 @@
             <a:r>
               <a:rPr lang="en-US" sz="1400" dirty="0">
                 <a:solidFill>
-                  <a:srgbClr val="16211F"/>
+                  <a:srgbClr val="241F38"/>
                 </a:solidFill>
                 <a:latin typeface="Calibri" pitchFamily="34" charset="0"/>
                 <a:ea typeface="Calibri" pitchFamily="34" charset="-122"/>
@@ -4424,7 +4424,7 @@
             <a:r>
               <a:rPr lang="en-US" sz="1400" dirty="0">
                 <a:solidFill>
-                  <a:srgbClr val="16211F"/>
+                  <a:srgbClr val="241F38"/>
                 </a:solidFill>
                 <a:latin typeface="Calibri" pitchFamily="34" charset="0"/>
                 <a:ea typeface="Calibri" pitchFamily="34" charset="-122"/>
@@ -4495,7 +4495,7 @@
             <a:r>
               <a:rPr lang="en-US" sz="3400" b="1" dirty="0">
                 <a:solidFill>
-                  <a:srgbClr val="0B3D3D"/>
+                  <a:srgbClr val="2E2457"/>
                 </a:solidFill>
                 <a:latin typeface="Cambria" pitchFamily="34" charset="0"/>
                 <a:ea typeface="Cambria" pitchFamily="34" charset="-122"/>
@@ -4524,11 +4524,11 @@
             </a:avLst>
           </a:prstGeom>
           <a:solidFill>
-            <a:srgbClr val="0B6E6E"/>
+            <a:srgbClr val="6A57B8"/>
           </a:solidFill>
           <a:ln w="12700">
             <a:solidFill>
-              <a:srgbClr val="0B6E6E"/>
+              <a:srgbClr val="6A57B8"/>
             </a:solidFill>
             <a:prstDash val="solid"/>
           </a:ln>
@@ -4607,11 +4607,11 @@
             </a:avLst>
           </a:prstGeom>
           <a:solidFill>
-            <a:srgbClr val="0B3D3D"/>
+            <a:srgbClr val="2E2457"/>
           </a:solidFill>
           <a:ln w="12700">
             <a:solidFill>
-              <a:srgbClr val="0B3D3D"/>
+              <a:srgbClr val="2E2457"/>
             </a:solidFill>
             <a:prstDash val="solid"/>
           </a:ln>
@@ -4690,11 +4690,11 @@
             </a:avLst>
           </a:prstGeom>
           <a:solidFill>
-            <a:srgbClr val="0B6E6E"/>
+            <a:srgbClr val="6A57B8"/>
           </a:solidFill>
           <a:ln w="12700">
             <a:solidFill>
-              <a:srgbClr val="0B6E6E"/>
+              <a:srgbClr val="6A57B8"/>
             </a:solidFill>
             <a:prstDash val="solid"/>
           </a:ln>
@@ -4773,11 +4773,11 @@
             </a:avLst>
           </a:prstGeom>
           <a:solidFill>
-            <a:srgbClr val="F4F6F5"/>
+            <a:srgbClr val="F4F1FC"/>
           </a:solidFill>
           <a:ln w="12700">
             <a:solidFill>
-              <a:srgbClr val="F4F6F5"/>
+              <a:srgbClr val="F4F1FC"/>
             </a:solidFill>
             <a:prstDash val="solid"/>
           </a:ln>
@@ -4810,7 +4810,7 @@
             <a:r>
               <a:rPr lang="en-US" sz="1500" b="1" dirty="0">
                 <a:solidFill>
-                  <a:srgbClr val="16211F"/>
+                  <a:srgbClr val="241F38"/>
                 </a:solidFill>
                 <a:latin typeface="Calibri" pitchFamily="34" charset="0"/>
                 <a:ea typeface="Calibri" pitchFamily="34" charset="-122"/>
@@ -4827,7 +4827,7 @@
             <a:r>
               <a:rPr lang="en-US" sz="1200" dirty="0">
                 <a:solidFill>
-                  <a:srgbClr val="16211F"/>
+                  <a:srgbClr val="241F38"/>
                 </a:solidFill>
                 <a:latin typeface="Calibri" pitchFamily="34" charset="0"/>
                 <a:ea typeface="Calibri" pitchFamily="34" charset="-122"/>
@@ -4856,11 +4856,11 @@
             </a:avLst>
           </a:prstGeom>
           <a:solidFill>
-            <a:srgbClr val="F4F6F5"/>
+            <a:srgbClr val="F4F1FC"/>
           </a:solidFill>
           <a:ln w="12700">
             <a:solidFill>
-              <a:srgbClr val="F4F6F5"/>
+              <a:srgbClr val="F4F1FC"/>
             </a:solidFill>
             <a:prstDash val="solid"/>
           </a:ln>
@@ -4893,7 +4893,7 @@
             <a:r>
               <a:rPr lang="en-US" sz="1500" b="1" dirty="0">
                 <a:solidFill>
-                  <a:srgbClr val="16211F"/>
+                  <a:srgbClr val="241F38"/>
                 </a:solidFill>
                 <a:latin typeface="Calibri" pitchFamily="34" charset="0"/>
                 <a:ea typeface="Calibri" pitchFamily="34" charset="-122"/>
@@ -4910,7 +4910,7 @@
             <a:r>
               <a:rPr lang="en-US" sz="1200" dirty="0">
                 <a:solidFill>
-                  <a:srgbClr val="16211F"/>
+                  <a:srgbClr val="241F38"/>
                 </a:solidFill>
                 <a:latin typeface="Calibri" pitchFamily="34" charset="0"/>
                 <a:ea typeface="Calibri" pitchFamily="34" charset="-122"/>
@@ -4939,11 +4939,11 @@
             </a:avLst>
           </a:prstGeom>
           <a:solidFill>
-            <a:srgbClr val="F4F6F5"/>
+            <a:srgbClr val="F4F1FC"/>
           </a:solidFill>
           <a:ln w="12700">
             <a:solidFill>
-              <a:srgbClr val="F4F6F5"/>
+              <a:srgbClr val="F4F1FC"/>
             </a:solidFill>
             <a:prstDash val="solid"/>
           </a:ln>
@@ -4976,7 +4976,7 @@
             <a:r>
               <a:rPr lang="en-US" sz="1500" b="1" dirty="0">
                 <a:solidFill>
-                  <a:srgbClr val="16211F"/>
+                  <a:srgbClr val="241F38"/>
                 </a:solidFill>
                 <a:latin typeface="Calibri" pitchFamily="34" charset="0"/>
                 <a:ea typeface="Calibri" pitchFamily="34" charset="-122"/>
@@ -4993,7 +4993,7 @@
             <a:r>
               <a:rPr lang="en-US" sz="1200" dirty="0">
                 <a:solidFill>
-                  <a:srgbClr val="16211F"/>
+                  <a:srgbClr val="241F38"/>
                 </a:solidFill>
                 <a:latin typeface="Calibri" pitchFamily="34" charset="0"/>
                 <a:ea typeface="Calibri" pitchFamily="34" charset="-122"/>
@@ -5032,7 +5032,7 @@
             <a:r>
               <a:rPr lang="en-US" sz="2000" b="1" dirty="0">
                 <a:solidFill>
-                  <a:srgbClr val="0B3D3D"/>
+                  <a:srgbClr val="2E2457"/>
                 </a:solidFill>
                 <a:latin typeface="Calibri" pitchFamily="34" charset="0"/>
                 <a:ea typeface="Calibri" pitchFamily="34" charset="-122"/>
@@ -5071,7 +5071,7 @@
             <a:r>
               <a:rPr lang="en-US" sz="2000" b="1" dirty="0">
                 <a:solidFill>
-                  <a:srgbClr val="0B3D3D"/>
+                  <a:srgbClr val="2E2457"/>
                 </a:solidFill>
                 <a:latin typeface="Calibri" pitchFamily="34" charset="0"/>
                 <a:ea typeface="Calibri" pitchFamily="34" charset="-122"/>
@@ -5110,7 +5110,7 @@
             <a:r>
               <a:rPr lang="en-US" sz="1300" dirty="0">
                 <a:solidFill>
-                  <a:srgbClr val="5D6B68"/>
+                  <a:srgbClr val="5F5978"/>
                 </a:solidFill>
                 <a:latin typeface="Calibri" pitchFamily="34" charset="0"/>
                 <a:ea typeface="Calibri" pitchFamily="34" charset="-122"/>
@@ -5181,7 +5181,7 @@
             <a:r>
               <a:rPr lang="en-US" sz="3400" b="1" dirty="0">
                 <a:solidFill>
-                  <a:srgbClr val="0B3D3D"/>
+                  <a:srgbClr val="2E2457"/>
                 </a:solidFill>
                 <a:latin typeface="Cambria" pitchFamily="34" charset="0"/>
                 <a:ea typeface="Cambria" pitchFamily="34" charset="-122"/>
@@ -5210,11 +5210,11 @@
             </a:avLst>
           </a:prstGeom>
           <a:solidFill>
-            <a:srgbClr val="F4F6F5"/>
+            <a:srgbClr val="F4F1FC"/>
           </a:solidFill>
           <a:ln w="12700">
             <a:solidFill>
-              <a:srgbClr val="F4F6F5"/>
+              <a:srgbClr val="F4F1FC"/>
             </a:solidFill>
             <a:prstDash val="solid"/>
           </a:ln>
@@ -5247,7 +5247,7 @@
             <a:r>
               <a:rPr lang="en-US" sz="1800" b="1" dirty="0">
                 <a:solidFill>
-                  <a:srgbClr val="0B6E6E"/>
+                  <a:srgbClr val="6A57B8"/>
                 </a:solidFill>
                 <a:latin typeface="Cambria" pitchFamily="34" charset="0"/>
                 <a:ea typeface="Cambria" pitchFamily="34" charset="-122"/>
@@ -5286,7 +5286,7 @@
             <a:r>
               <a:rPr lang="en-US" sz="1400" dirty="0">
                 <a:solidFill>
-                  <a:srgbClr val="16211F"/>
+                  <a:srgbClr val="241F38"/>
                 </a:solidFill>
                 <a:latin typeface="Calibri" pitchFamily="34" charset="0"/>
                 <a:ea typeface="Calibri" pitchFamily="34" charset="-122"/>
@@ -5315,11 +5315,11 @@
             </a:avLst>
           </a:prstGeom>
           <a:solidFill>
-            <a:srgbClr val="F4F6F5"/>
+            <a:srgbClr val="F4F1FC"/>
           </a:solidFill>
           <a:ln w="12700">
             <a:solidFill>
-              <a:srgbClr val="F4F6F5"/>
+              <a:srgbClr val="F4F1FC"/>
             </a:solidFill>
             <a:prstDash val="solid"/>
           </a:ln>
@@ -5352,7 +5352,7 @@
             <a:r>
               <a:rPr lang="en-US" sz="1800" b="1" dirty="0">
                 <a:solidFill>
-                  <a:srgbClr val="0B6E6E"/>
+                  <a:srgbClr val="6A57B8"/>
                 </a:solidFill>
                 <a:latin typeface="Cambria" pitchFamily="34" charset="0"/>
                 <a:ea typeface="Cambria" pitchFamily="34" charset="-122"/>
@@ -5391,7 +5391,7 @@
             <a:r>
               <a:rPr lang="en-US" sz="1400" dirty="0">
                 <a:solidFill>
-                  <a:srgbClr val="16211F"/>
+                  <a:srgbClr val="241F38"/>
                 </a:solidFill>
                 <a:latin typeface="Calibri" pitchFamily="34" charset="0"/>
                 <a:ea typeface="Calibri" pitchFamily="34" charset="-122"/>
@@ -5420,11 +5420,11 @@
             </a:avLst>
           </a:prstGeom>
           <a:solidFill>
-            <a:srgbClr val="F4F6F5"/>
+            <a:srgbClr val="F4F1FC"/>
           </a:solidFill>
           <a:ln w="12700">
             <a:solidFill>
-              <a:srgbClr val="F4F6F5"/>
+              <a:srgbClr val="F4F1FC"/>
             </a:solidFill>
             <a:prstDash val="solid"/>
           </a:ln>
@@ -5457,7 +5457,7 @@
             <a:r>
               <a:rPr lang="en-US" sz="1800" b="1" dirty="0">
                 <a:solidFill>
-                  <a:srgbClr val="0B6E6E"/>
+                  <a:srgbClr val="6A57B8"/>
                 </a:solidFill>
                 <a:latin typeface="Cambria" pitchFamily="34" charset="0"/>
                 <a:ea typeface="Cambria" pitchFamily="34" charset="-122"/>
@@ -5496,7 +5496,7 @@
             <a:r>
               <a:rPr lang="en-US" sz="1400" dirty="0">
                 <a:solidFill>
-                  <a:srgbClr val="16211F"/>
+                  <a:srgbClr val="241F38"/>
                 </a:solidFill>
                 <a:latin typeface="Calibri" pitchFamily="34" charset="0"/>
                 <a:ea typeface="Calibri" pitchFamily="34" charset="-122"/>
@@ -5525,11 +5525,11 @@
             </a:avLst>
           </a:prstGeom>
           <a:solidFill>
-            <a:srgbClr val="F4F6F5"/>
+            <a:srgbClr val="F4F1FC"/>
           </a:solidFill>
           <a:ln w="12700">
             <a:solidFill>
-              <a:srgbClr val="F4F6F5"/>
+              <a:srgbClr val="F4F1FC"/>
             </a:solidFill>
             <a:prstDash val="solid"/>
           </a:ln>
@@ -5562,7 +5562,7 @@
             <a:r>
               <a:rPr lang="en-US" sz="1800" b="1" dirty="0">
                 <a:solidFill>
-                  <a:srgbClr val="0B6E6E"/>
+                  <a:srgbClr val="6A57B8"/>
                 </a:solidFill>
                 <a:latin typeface="Cambria" pitchFamily="34" charset="0"/>
                 <a:ea typeface="Cambria" pitchFamily="34" charset="-122"/>
@@ -5601,7 +5601,7 @@
             <a:r>
               <a:rPr lang="en-US" sz="1400" dirty="0">
                 <a:solidFill>
-                  <a:srgbClr val="16211F"/>
+                  <a:srgbClr val="241F38"/>
                 </a:solidFill>
                 <a:latin typeface="Calibri" pitchFamily="34" charset="0"/>
                 <a:ea typeface="Calibri" pitchFamily="34" charset="-122"/>
@@ -5627,7 +5627,7 @@
     <p:bg>
       <p:bgPr>
         <a:solidFill>
-          <a:srgbClr val="0B3D3D"/>
+          <a:srgbClr val="2E2457"/>
         </a:solidFill>
       </p:bgPr>
     </p:bg>
@@ -5838,7 +5838,7 @@
             <a:r>
               <a:rPr lang="en-US" sz="4400" b="1" dirty="0">
                 <a:solidFill>
-                  <a:srgbClr val="F2A33A"/>
+                  <a:srgbClr val="9FD3F0"/>
                 </a:solidFill>
                 <a:latin typeface="Cambria" pitchFamily="34" charset="0"/>
                 <a:ea typeface="Cambria" pitchFamily="34" charset="-122"/>
@@ -5877,7 +5877,7 @@
             <a:r>
               <a:rPr lang="en-US" sz="1400" dirty="0">
                 <a:solidFill>
-                  <a:srgbClr val="CFE3E1"/>
+                  <a:srgbClr val="DDD4F6"/>
                 </a:solidFill>
                 <a:latin typeface="Calibri" pitchFamily="34" charset="0"/>
                 <a:ea typeface="Calibri" pitchFamily="34" charset="-122"/>
@@ -5916,7 +5916,7 @@
             <a:r>
               <a:rPr lang="en-US" sz="4400" b="1" dirty="0">
                 <a:solidFill>
-                  <a:srgbClr val="F2A33A"/>
+                  <a:srgbClr val="9FD3F0"/>
                 </a:solidFill>
                 <a:latin typeface="Cambria" pitchFamily="34" charset="0"/>
                 <a:ea typeface="Cambria" pitchFamily="34" charset="-122"/>
@@ -5955,7 +5955,7 @@
             <a:r>
               <a:rPr lang="en-US" sz="1400" dirty="0">
                 <a:solidFill>
-                  <a:srgbClr val="CFE3E1"/>
+                  <a:srgbClr val="DDD4F6"/>
                 </a:solidFill>
                 <a:latin typeface="Calibri" pitchFamily="34" charset="0"/>
                 <a:ea typeface="Calibri" pitchFamily="34" charset="-122"/>
@@ -5994,7 +5994,7 @@
             <a:r>
               <a:rPr lang="en-US" sz="4400" b="1" dirty="0">
                 <a:solidFill>
-                  <a:srgbClr val="F2A33A"/>
+                  <a:srgbClr val="9FD3F0"/>
                 </a:solidFill>
                 <a:latin typeface="Cambria" pitchFamily="34" charset="0"/>
                 <a:ea typeface="Cambria" pitchFamily="34" charset="-122"/>
@@ -6033,7 +6033,7 @@
             <a:r>
               <a:rPr lang="en-US" sz="1400" dirty="0">
                 <a:solidFill>
-                  <a:srgbClr val="CFE3E1"/>
+                  <a:srgbClr val="DDD4F6"/>
                 </a:solidFill>
                 <a:latin typeface="Calibri" pitchFamily="34" charset="0"/>
                 <a:ea typeface="Calibri" pitchFamily="34" charset="-122"/>

</xml_diff>